<commit_message>
Subindo um backup banco de dados
</commit_message>
<xml_diff>
--- a/G4.pptx
+++ b/G4.pptx
@@ -16,7 +16,7 @@
   <p:notesSz cx="6858000" cy="9144000"/>
   <p:embeddedFontLst>
     <p:embeddedFont>
-      <p:font typeface="Bebas Neue" panose="020F0502020204030204" pitchFamily="34" charset="0"/>
+      <p:font typeface="Bebas Neue" panose="020B0606020202050201" pitchFamily="34" charset="0"/>
       <p:regular r:id="rId6"/>
     </p:embeddedFont>
     <p:embeddedFont>
@@ -13455,7 +13455,7 @@
                 <a:cs typeface="Maven Pro"/>
                 <a:sym typeface="Maven Pro"/>
               </a:rPr>
-              <a:t>: O problema é a falta de uma análise sistemática e eficiente das reclamações, que permite identificar quais produtos, modelos e motivos geram mais insatisfações, facilitando a tomada de decisões para melhorias.</a:t>
+              <a:t>: O problema é a falta de uma análise sistemática e eficiente das reclamações, que permite identificar quais produtos ou serviços geram mais insatisfações, facilitando a tomada de decisões para melhorias.</a:t>
             </a:r>
           </a:p>
           <a:p>

</xml_diff>